<commit_message>
Website: drei neue Decks über die App
Neue Beispiel-Decks, gebaut über den Deckwerk-MCP mit eigenem Design je Deck:
- deckwerk: Produktvorstellung (12 Folien, im Look der App)
- vortrag: Präsentiermodus, Fernbedienung, Laser, Morph (8 Folien, Bühnenlicht)
- agenten: MCP-Server und Skill für Claude Code/Codex (8 Folien, Terminal)
folien.mjs rendert sie zuerst und nennt eigene Themes beim Namen; og.jpg wird
nicht mehr überschrieben. Live-Demo kennt die neuen Decks, ohne Treffer zeigt
sie das Deckwerk-Deck. Folien-Wand und „Weiter“ zeigen die neuen Folien.

Co-Authored-By: Claude Opus 5.5 <noreply@anthropic.com>
</commit_message>
<xml_diff>
--- a/website/public/beispiele/strategie.pptx
+++ b/website/public/beispiele/strategie.pptx
@@ -134,26 +134,26 @@
   <p:extLst>
     <p:ext uri="{521415D9-36F7-43E2-AB2F-B90AF26B5E84}">
       <p14:sectionLst xmlns:p14="http://schemas.microsoft.com/office/powerpoint/2010/main">
-        <p14:section name="Einstieg" id="{96D40F23-8530-4FAA-9AD7-51B443C57889}">
+        <p14:section name="Einstieg" id="{79A98B86-6827-42AA-BFAC-92B574BC1DB4}">
           <p14:sldIdLst>
             <p14:sldId id="256"/>
             <p14:sldId id="257"/>
           </p14:sldIdLst>
         </p14:section>
-        <p14:section name="01 Ausgangslage" id="{48DEB6AB-91F2-4558-AF5D-C8D31B00203C}">
+        <p14:section name="01 Ausgangslage" id="{1C78D6B7-9AA6-4DDD-8B73-9AD19931BE42}">
           <p14:sldIdLst>
             <p14:sldId id="258"/>
             <p14:sldId id="259"/>
             <p14:sldId id="260"/>
           </p14:sldIdLst>
         </p14:section>
-        <p14:section name="02 Drei Schwerpunkte" id="{2A568D7C-286D-4537-B272-C5C407CAA68D}">
+        <p14:section name="02 Drei Schwerpunkte" id="{03A40927-C6CE-43F2-BF6B-61B8DD668214}">
           <p14:sldIdLst>
             <p14:sldId id="261"/>
             <p14:sldId id="262"/>
           </p14:sldIdLst>
         </p14:section>
-        <p14:section name="03 Weg bis 2027" id="{F5EBC1A3-7AE4-4664-9412-0D36BD69C874}">
+        <p14:section name="03 Weg bis 2027" id="{6DFA560F-3983-4117-9E9F-A2364EDF6E3E}">
           <p14:sldIdLst>
             <p14:sldId id="263"/>
             <p14:sldId id="264"/>

</xml_diff>